<commit_message>
Rebuild Lecture-3 with charts and visual layouts
5 embedded images: sigmoid curve, phishing URL feature flags, coefficient
bar chart, predict vs predict_proba diagram, threshold tuning chart.
Uses 2-Column, Bullets+Pull Quote, and Title Only layouts.
</commit_message>
<xml_diff>
--- a/stage1_classic_ml/03_logistic_regression/Lecture-3-Logistic-Regression.pptx
+++ b/stage1_classic_ml/03_logistic_regression/Lecture-3-Logistic-Regression.pptx
@@ -25,6 +25,8 @@
     <p:sldId id="267" r:id="rId23"/>
     <p:sldId id="268" r:id="rId24"/>
     <p:sldId id="269" r:id="rId25"/>
+    <p:sldId id="270" r:id="rId26"/>
+    <p:sldId id="271" r:id="rId27"/>
   </p:sldIdLst>
   <p:sldSz cx="12188825" cy="6858000"/>
   <p:notesSz cx="7010400" cy="9296400"/>
@@ -8395,12 +8397,12 @@
       <p:grpSpPr/>
       <p:sp>
         <p:nvSpPr>
-          <p:cNvPr id="2" name="Title 1"/>
+          <p:cNvPr id="2" name="Text Placeholder 1"/>
           <p:cNvSpPr>
             <a:spLocks noGrp="1"/>
           </p:cNvSpPr>
           <p:nvPr>
-            <p:ph type="title"/>
+            <p:ph type="body" idx="13" sz="quarter"/>
           </p:nvPr>
         </p:nvSpPr>
         <p:spPr/>
@@ -8409,19 +8411,24 @@
           <a:lstStyle/>
           <a:p>
             <a:r>
-              <a:t>Feature Coefficients — Interpretability</a:t>
+              <a:t>Predictions &amp;</a:t>
+            </a:r>
+          </a:p>
+          <a:p>
+            <a:r>
+              <a:t>Thresholds</a:t>
             </a:r>
           </a:p>
         </p:txBody>
       </p:sp>
       <p:sp>
         <p:nvSpPr>
-          <p:cNvPr id="3" name="Content Placeholder 2"/>
+          <p:cNvPr id="3" name="Text Placeholder 2"/>
           <p:cNvSpPr>
             <a:spLocks noGrp="1"/>
           </p:cNvSpPr>
           <p:nvPr>
-            <p:ph idx="1"/>
+            <p:ph type="body" idx="16" sz="quarter"/>
           </p:nvPr>
         </p:nvSpPr>
         <p:spPr/>
@@ -8429,51 +8436,8 @@
           <a:bodyPr/>
           <a:lstStyle/>
           <a:p>
-            <a:pPr/>
-            <a:r>
-              <a:t>model.coef_ tells you which features matter most</a:t>
-            </a:r>
-          </a:p>
-          <a:p>
-            <a:pPr lvl="1"/>
-            <a:r>
-              <a:t>Positive coefficient → increases P(phishing)</a:t>
-            </a:r>
-          </a:p>
-          <a:p>
-            <a:pPr lvl="1"/>
-            <a:r>
-              <a:t>Negative coefficient → decreases P(phishing)</a:t>
-            </a:r>
-          </a:p>
-          <a:p>
-            <a:pPr/>
-            <a:r>
-              <a:t>Example output:</a:t>
-            </a:r>
-          </a:p>
-          <a:p>
-            <a:pPr lvl="1"/>
-            <a:r>
-              <a:t>url_length: +0.82    (longer URLs → more suspicious)</a:t>
-            </a:r>
-          </a:p>
-          <a:p>
-            <a:pPr lvl="1"/>
-            <a:r>
-              <a:t>num_dots: +1.45       (many subdomains → highly suspicious)</a:t>
-            </a:r>
-          </a:p>
-          <a:p>
-            <a:pPr lvl="1"/>
-            <a:r>
-              <a:t>domain_age: -0.91    (older domains → more trustworthy)</a:t>
-            </a:r>
-          </a:p>
-          <a:p>
-            <a:pPr/>
-            <a:r>
-              <a:t>Great for explaining your detector to non-technical stakeholders</a:t>
+            <a:r>
+              <a:t>03</a:t>
             </a:r>
           </a:p>
         </p:txBody>
@@ -8498,12 +8462,12 @@
       <p:grpSpPr/>
       <p:sp>
         <p:nvSpPr>
-          <p:cNvPr id="2" name="Text Placeholder 1"/>
+          <p:cNvPr id="2" name="Title 1"/>
           <p:cNvSpPr>
             <a:spLocks noGrp="1"/>
           </p:cNvSpPr>
           <p:nvPr>
-            <p:ph type="body" idx="13" sz="quarter"/>
+            <p:ph type="title"/>
           </p:nvPr>
         </p:nvSpPr>
         <p:spPr/>
@@ -8512,32 +8476,35 @@
           <a:lstStyle/>
           <a:p>
             <a:r>
-              <a:t>Workshop</a:t>
+              <a:t>Two Ways to Get Predictions</a:t>
             </a:r>
           </a:p>
         </p:txBody>
       </p:sp>
-      <p:sp>
-        <p:nvSpPr>
-          <p:cNvPr id="3" name="Text Placeholder 2"/>
-          <p:cNvSpPr>
-            <a:spLocks noGrp="1"/>
-          </p:cNvSpPr>
-          <p:nvPr>
-            <p:ph type="body" idx="16" sz="quarter"/>
-          </p:nvPr>
-        </p:nvSpPr>
-        <p:spPr/>
-        <p:txBody>
-          <a:bodyPr/>
-          <a:lstStyle/>
-          <a:p>
-            <a:r>
-              <a:t>04</a:t>
-            </a:r>
-          </a:p>
-        </p:txBody>
-      </p:sp>
+      <p:pic>
+        <p:nvPicPr>
+          <p:cNvPr id="3" name="Picture 2" descr="log_predict.png"/>
+          <p:cNvPicPr>
+            <a:picLocks noChangeAspect="1"/>
+          </p:cNvPicPr>
+          <p:nvPr/>
+        </p:nvPicPr>
+        <p:blipFill>
+          <a:blip r:embed="rId2"/>
+          <a:stretch>
+            <a:fillRect/>
+          </a:stretch>
+        </p:blipFill>
+        <p:spPr>
+          <a:xfrm>
+            <a:off x="1097280" y="1645920"/>
+            <a:ext cx="10058400" cy="3332314"/>
+          </a:xfrm>
+          <a:prstGeom prst="rect">
+            <a:avLst/>
+          </a:prstGeom>
+        </p:spPr>
+      </p:pic>
     </p:spTree>
   </p:cSld>
   <p:clrMapOvr>
@@ -8572,75 +8539,35 @@
           <a:lstStyle/>
           <a:p>
             <a:r>
-              <a:t>Workshop — 4 Exercises</a:t>
+              <a:t>Threshold Tuning — Balancing Precision and Recall</a:t>
             </a:r>
           </a:p>
         </p:txBody>
       </p:sp>
-      <p:sp>
-        <p:nvSpPr>
-          <p:cNvPr id="3" name="Content Placeholder 2"/>
-          <p:cNvSpPr>
-            <a:spLocks noGrp="1"/>
-          </p:cNvSpPr>
-          <p:nvPr>
-            <p:ph idx="1"/>
-          </p:nvPr>
-        </p:nvSpPr>
-        <p:spPr/>
-        <p:txBody>
-          <a:bodyPr/>
-          <a:lstStyle/>
-          <a:p>
-            <a:pPr/>
-            <a:r>
-              <a:t>Exercise 1: From regression to classification — sigmoid, probability outputs</a:t>
-            </a:r>
-          </a:p>
-          <a:p>
-            <a:pPr/>
-            <a:r>
-              <a:t>Exercise 2: Feature engineering URLs — extract security-relevant features</a:t>
-            </a:r>
-          </a:p>
-          <a:p>
-            <a:pPr/>
-            <a:r>
-              <a:t>Exercise 3: Train and evaluate — LogisticRegression, classification report</a:t>
-            </a:r>
-          </a:p>
-          <a:p>
-            <a:pPr/>
-            <a:r>
-              <a:t>Exercise 4: Threshold tuning — predict_proba(), precision-recall tradeoff</a:t>
-            </a:r>
-          </a:p>
-          <a:p>
-            <a:pPr/>
-            <a:r>
-              <a:t>Each exercise has:</a:t>
-            </a:r>
-          </a:p>
-          <a:p>
-            <a:pPr lvl="1"/>
-            <a:r>
-              <a:t>lecture.md — concept explanation</a:t>
-            </a:r>
-          </a:p>
-          <a:p>
-            <a:pPr lvl="1"/>
-            <a:r>
-              <a:t>handson.md — step-by-step lab</a:t>
-            </a:r>
-          </a:p>
-          <a:p>
-            <a:pPr lvl="1"/>
-            <a:r>
-              <a:t>solution_logistic_regression.py — reference implementation</a:t>
-            </a:r>
-          </a:p>
-        </p:txBody>
-      </p:sp>
+      <p:pic>
+        <p:nvPicPr>
+          <p:cNvPr id="3" name="Picture 2" descr="log_threshold.png"/>
+          <p:cNvPicPr>
+            <a:picLocks noChangeAspect="1"/>
+          </p:cNvPicPr>
+          <p:nvPr/>
+        </p:nvPicPr>
+        <p:blipFill>
+          <a:blip r:embed="rId2"/>
+          <a:stretch>
+            <a:fillRect/>
+          </a:stretch>
+        </p:blipFill>
+        <p:spPr>
+          <a:xfrm>
+            <a:off x="914400" y="1371600"/>
+            <a:ext cx="10332720" cy="4133088"/>
+          </a:xfrm>
+          <a:prstGeom prst="rect">
+            <a:avLst/>
+          </a:prstGeom>
+        </p:spPr>
+      </p:pic>
     </p:spTree>
   </p:cSld>
   <p:clrMapOvr>
@@ -8666,7 +8593,7 @@
             <a:spLocks noGrp="1"/>
           </p:cNvSpPr>
           <p:nvPr>
-            <p:ph type="body" idx="12" sz="quarter"/>
+            <p:ph type="body" idx="13" sz="quarter"/>
           </p:nvPr>
         </p:nvSpPr>
         <p:spPr/>
@@ -8674,51 +8601,20 @@
           <a:bodyPr/>
           <a:lstStyle/>
           <a:p>
-            <a:pPr/>
-            <a:r>
-              <a:t>Logistic regression predicts a probability, then applies a threshold for a binary decision</a:t>
-            </a:r>
-          </a:p>
-          <a:p>
-            <a:pPr/>
-            <a:r>
-              <a:t>The sigmoid function maps any value to [0, 1]</a:t>
-            </a:r>
-          </a:p>
-          <a:p>
-            <a:pPr/>
-            <a:r>
-              <a:t>Phishing detection: extract URL features → train classifier → get probabilities</a:t>
-            </a:r>
-          </a:p>
-          <a:p>
-            <a:pPr/>
-            <a:r>
-              <a:t>Feature coefficients tell you which features drive the prediction</a:t>
-            </a:r>
-          </a:p>
-          <a:p>
-            <a:pPr/>
-            <a:r>
-              <a:t>Threshold tuning lets you balance precision vs recall for your use case</a:t>
-            </a:r>
-          </a:p>
-          <a:p>
-            <a:pPr/>
-            <a:r>
-              <a:t>Next: Lesson 1.4 — Decision Trees</a:t>
+            <a:r>
+              <a:t>Workshop</a:t>
             </a:r>
           </a:p>
         </p:txBody>
       </p:sp>
       <p:sp>
         <p:nvSpPr>
-          <p:cNvPr id="3" name="Title 2"/>
+          <p:cNvPr id="3" name="Text Placeholder 2"/>
           <p:cNvSpPr>
             <a:spLocks noGrp="1"/>
           </p:cNvSpPr>
           <p:nvPr>
-            <p:ph type="title"/>
+            <p:ph type="body" idx="16" sz="quarter"/>
           </p:nvPr>
         </p:nvSpPr>
         <p:spPr/>
@@ -8727,7 +8623,7 @@
           <a:lstStyle/>
           <a:p>
             <a:r>
-              <a:t>Summary</a:t>
+              <a:t>04</a:t>
             </a:r>
           </a:p>
         </p:txBody>
@@ -8752,6 +8648,191 @@
       <p:grpSpPr/>
       <p:sp>
         <p:nvSpPr>
+          <p:cNvPr id="2" name="Title 1"/>
+          <p:cNvSpPr>
+            <a:spLocks noGrp="1"/>
+          </p:cNvSpPr>
+          <p:nvPr>
+            <p:ph type="title"/>
+          </p:nvPr>
+        </p:nvSpPr>
+        <p:spPr/>
+        <p:txBody>
+          <a:bodyPr/>
+          <a:lstStyle/>
+          <a:p>
+            <a:r>
+              <a:t>Workshop — 4 Exercises</a:t>
+            </a:r>
+          </a:p>
+        </p:txBody>
+      </p:sp>
+      <p:sp>
+        <p:nvSpPr>
+          <p:cNvPr id="3" name="Content Placeholder 2"/>
+          <p:cNvSpPr>
+            <a:spLocks noGrp="1"/>
+          </p:cNvSpPr>
+          <p:nvPr>
+            <p:ph idx="1"/>
+          </p:nvPr>
+        </p:nvSpPr>
+        <p:spPr/>
+        <p:txBody>
+          <a:bodyPr/>
+          <a:lstStyle/>
+          <a:p>
+            <a:pPr/>
+            <a:r>
+              <a:t>Exercise 1: From regression to classification — sigmoid, probability outputs</a:t>
+            </a:r>
+          </a:p>
+          <a:p>
+            <a:pPr/>
+            <a:r>
+              <a:t>Exercise 2: Feature engineering URLs — extract security-relevant features</a:t>
+            </a:r>
+          </a:p>
+          <a:p>
+            <a:pPr/>
+            <a:r>
+              <a:t>Exercise 3: Train and evaluate — LogisticRegression, classification report, confusion matrix</a:t>
+            </a:r>
+          </a:p>
+          <a:p>
+            <a:pPr/>
+            <a:r>
+              <a:t>Exercise 4: Threshold tuning — predict_proba(), precision-recall tradeoff</a:t>
+            </a:r>
+          </a:p>
+          <a:p>
+            <a:pPr/>
+          </a:p>
+          <a:p>
+            <a:pPr/>
+            <a:r>
+              <a:t>Each exercise: lecture.md → handson.md → solution_logistic_regression.py</a:t>
+            </a:r>
+          </a:p>
+        </p:txBody>
+      </p:sp>
+    </p:spTree>
+  </p:cSld>
+  <p:clrMapOvr>
+    <a:masterClrMapping/>
+  </p:clrMapOvr>
+</p:sld>
+</file>
+
+<file path=ppt/slides/slide15.xml><?xml version="1.0" encoding="utf-8"?>
+<p:sld xmlns:a="http://schemas.openxmlformats.org/drawingml/2006/main" xmlns:p="http://schemas.openxmlformats.org/presentationml/2006/main" xmlns:r="http://schemas.openxmlformats.org/officeDocument/2006/relationships">
+  <p:cSld>
+    <p:spTree>
+      <p:nvGrpSpPr>
+        <p:cNvPr id="1" name=""/>
+        <p:cNvGrpSpPr/>
+        <p:nvPr/>
+      </p:nvGrpSpPr>
+      <p:grpSpPr/>
+      <p:sp>
+        <p:nvSpPr>
+          <p:cNvPr id="2" name="Text Placeholder 1"/>
+          <p:cNvSpPr>
+            <a:spLocks noGrp="1"/>
+          </p:cNvSpPr>
+          <p:nvPr>
+            <p:ph type="body" idx="12" sz="quarter"/>
+          </p:nvPr>
+        </p:nvSpPr>
+        <p:spPr/>
+        <p:txBody>
+          <a:bodyPr/>
+          <a:lstStyle/>
+          <a:p>
+            <a:pPr/>
+            <a:r>
+              <a:t>Logistic regression predicts a probability, then applies a threshold for a binary decision</a:t>
+            </a:r>
+          </a:p>
+          <a:p>
+            <a:pPr/>
+            <a:r>
+              <a:t>The sigmoid function maps any value to [0, 1]</a:t>
+            </a:r>
+          </a:p>
+          <a:p>
+            <a:pPr/>
+            <a:r>
+              <a:t>Phishing detection: extract URL features → train classifier → get probabilities</a:t>
+            </a:r>
+          </a:p>
+          <a:p>
+            <a:pPr/>
+            <a:r>
+              <a:t>Feature coefficients tell you which features drive the prediction — interpretable</a:t>
+            </a:r>
+          </a:p>
+          <a:p>
+            <a:pPr/>
+            <a:r>
+              <a:t>predict_proba() gives more control than predict() — always prefer it in security</a:t>
+            </a:r>
+          </a:p>
+          <a:p>
+            <a:pPr/>
+            <a:r>
+              <a:t>Threshold tuning: lower = catch more (more false alarms), higher = fewer alarms (miss some)</a:t>
+            </a:r>
+          </a:p>
+          <a:p>
+            <a:pPr/>
+            <a:r>
+              <a:t>Next: Lesson 1.4 — Decision Trees</a:t>
+            </a:r>
+          </a:p>
+        </p:txBody>
+      </p:sp>
+      <p:sp>
+        <p:nvSpPr>
+          <p:cNvPr id="3" name="Title 2"/>
+          <p:cNvSpPr>
+            <a:spLocks noGrp="1"/>
+          </p:cNvSpPr>
+          <p:nvPr>
+            <p:ph type="title"/>
+          </p:nvPr>
+        </p:nvSpPr>
+        <p:spPr/>
+        <p:txBody>
+          <a:bodyPr/>
+          <a:lstStyle/>
+          <a:p>
+            <a:r>
+              <a:t>Summary</a:t>
+            </a:r>
+          </a:p>
+        </p:txBody>
+      </p:sp>
+    </p:spTree>
+  </p:cSld>
+  <p:clrMapOvr>
+    <a:masterClrMapping/>
+  </p:clrMapOvr>
+</p:sld>
+</file>
+
+<file path=ppt/slides/slide16.xml><?xml version="1.0" encoding="utf-8"?>
+<p:sld xmlns:a="http://schemas.openxmlformats.org/drawingml/2006/main" xmlns:p="http://schemas.openxmlformats.org/presentationml/2006/main" xmlns:r="http://schemas.openxmlformats.org/officeDocument/2006/relationships">
+  <p:cSld>
+    <p:spTree>
+      <p:nvGrpSpPr>
+        <p:cNvPr id="1" name=""/>
+        <p:cNvGrpSpPr/>
+        <p:nvPr/>
+      </p:nvGrpSpPr>
+      <p:grpSpPr/>
+      <p:sp>
+        <p:nvSpPr>
           <p:cNvPr id="2" name="Text Placeholder 1"/>
           <p:cNvSpPr>
             <a:spLocks noGrp="1"/>
@@ -8827,31 +8908,37 @@
           <a:p>
             <a:pPr/>
             <a:r>
-              <a:t>From regression to classification</a:t>
+              <a:t>From regression to classification — the sigmoid function</a:t>
             </a:r>
           </a:p>
           <a:p>
             <a:pPr/>
             <a:r>
-              <a:t>The sigmoid function and probability</a:t>
+              <a:t>Real-life example: phishing URL detector</a:t>
             </a:r>
           </a:p>
           <a:p>
             <a:pPr/>
             <a:r>
-              <a:t>Real-life example: phishing URL detector</a:t>
+              <a:t>Feature coefficients — what matters most</a:t>
             </a:r>
           </a:p>
           <a:p>
             <a:pPr/>
             <a:r>
+              <a:t>predict() vs predict_proba() — hard labels vs probabilities</a:t>
+            </a:r>
+          </a:p>
+          <a:p>
+            <a:pPr/>
+            <a:r>
               <a:t>Decision boundaries and thresholds</a:t>
             </a:r>
           </a:p>
           <a:p>
             <a:pPr/>
             <a:r>
-              <a:t>Feature coefficients — what matters most</a:t>
+              <a:t>Threshold tuning for operational priorities</a:t>
             </a:r>
           </a:p>
           <a:p>
@@ -8994,7 +9081,7 @@
             <a:spLocks noGrp="1"/>
           </p:cNvSpPr>
           <p:nvPr>
-            <p:ph idx="1"/>
+            <p:ph idx="2" sz="half"/>
           </p:nvPr>
         </p:nvSpPr>
         <p:spPr/>
@@ -9004,43 +9091,89 @@
           <a:p>
             <a:pPr/>
             <a:r>
-              <a:t>Linear regression predicts a number (response time in ms)</a:t>
+              <a:t>Linear Regression (Lesson 1.2)</a:t>
             </a:r>
           </a:p>
           <a:p>
             <a:pPr/>
-            <a:r>
-              <a:t>Logistic regression predicts a probability → then a binary decision</a:t>
-            </a:r>
           </a:p>
           <a:p>
             <a:pPr/>
             <a:r>
-              <a:t>P(phishing) = sigmoid( w1×url_length + w2×num_dots + ... + bias )</a:t>
+              <a:t>Predicts a number:</a:t>
+            </a:r>
+          </a:p>
+          <a:p>
+            <a:pPr lvl="1"/>
+            <a:r>
+              <a:t>response_time = 247.3 ms</a:t>
             </a:r>
           </a:p>
           <a:p>
             <a:pPr/>
-            <a:r>
-              <a:t>The sigmoid function squashes any number into [0, 1]</a:t>
+          </a:p>
+          <a:p>
+            <a:pPr/>
+            <a:r>
+              <a:t>Output is continuous</a:t>
+            </a:r>
+          </a:p>
+          <a:p>
+            <a:pPr/>
+            <a:r>
+              <a:t>Can be any value</a:t>
+            </a:r>
+          </a:p>
+        </p:txBody>
+      </p:sp>
+      <p:sp>
+        <p:nvSpPr>
+          <p:cNvPr id="4" name="Content Placeholder 3"/>
+          <p:cNvSpPr>
+            <a:spLocks noGrp="1"/>
+          </p:cNvSpPr>
+          <p:nvPr>
+            <p:ph idx="12" sz="half"/>
+          </p:nvPr>
+        </p:nvSpPr>
+        <p:spPr/>
+        <p:txBody>
+          <a:bodyPr/>
+          <a:lstStyle/>
+          <a:p>
+            <a:pPr/>
+            <a:r>
+              <a:t>Logistic Regression (this lesson)</a:t>
+            </a:r>
+          </a:p>
+          <a:p>
+            <a:pPr/>
+          </a:p>
+          <a:p>
+            <a:pPr/>
+            <a:r>
+              <a:t>Predicts a probability:</a:t>
             </a:r>
           </a:p>
           <a:p>
             <a:pPr lvl="1"/>
             <a:r>
-              <a:t>sigmoid(x) = 1 / (1 + e^(-x))</a:t>
+              <a:t>P(phishing) = 0.87</a:t>
             </a:r>
           </a:p>
           <a:p>
             <a:pPr/>
-            <a:r>
-              <a:t>If P(phishing) &gt; 0.5 → classify as phishing</a:t>
-            </a:r>
           </a:p>
           <a:p>
             <a:pPr/>
             <a:r>
-              <a:t>The 0.5 threshold is not always the right choice (more on this later)</a:t>
+              <a:t>Then applies a threshold:</a:t>
+            </a:r>
+          </a:p>
+          <a:p>
+            <a:pPr/>
+            <a:r>
+              <a:t>If P &gt; 0.5 → classify as phishing</a:t>
             </a:r>
           </a:p>
         </p:txBody>
@@ -9065,12 +9198,12 @@
       <p:grpSpPr/>
       <p:sp>
         <p:nvSpPr>
-          <p:cNvPr id="2" name="Text Placeholder 1"/>
+          <p:cNvPr id="2" name="Title 1"/>
           <p:cNvSpPr>
             <a:spLocks noGrp="1"/>
           </p:cNvSpPr>
           <p:nvPr>
-            <p:ph type="body" idx="13" sz="quarter"/>
+            <p:ph type="title"/>
           </p:nvPr>
         </p:nvSpPr>
         <p:spPr/>
@@ -9079,37 +9212,35 @@
           <a:lstStyle/>
           <a:p>
             <a:r>
-              <a:t>Phishing URL</a:t>
-            </a:r>
-          </a:p>
-          <a:p>
-            <a:r>
-              <a:t>Detection</a:t>
+              <a:t>The Sigmoid Function</a:t>
             </a:r>
           </a:p>
         </p:txBody>
       </p:sp>
-      <p:sp>
-        <p:nvSpPr>
-          <p:cNvPr id="3" name="Text Placeholder 2"/>
-          <p:cNvSpPr>
-            <a:spLocks noGrp="1"/>
-          </p:cNvSpPr>
-          <p:nvPr>
-            <p:ph type="body" idx="16" sz="quarter"/>
-          </p:nvPr>
-        </p:nvSpPr>
-        <p:spPr/>
-        <p:txBody>
-          <a:bodyPr/>
-          <a:lstStyle/>
-          <a:p>
-            <a:r>
-              <a:t>02</a:t>
-            </a:r>
-          </a:p>
-        </p:txBody>
-      </p:sp>
+      <p:pic>
+        <p:nvPicPr>
+          <p:cNvPr id="3" name="Picture 2" descr="log_sigmoid.png"/>
+          <p:cNvPicPr>
+            <a:picLocks noChangeAspect="1"/>
+          </p:cNvPicPr>
+          <p:nvPr/>
+        </p:nvPicPr>
+        <p:blipFill>
+          <a:blip r:embed="rId2"/>
+          <a:stretch>
+            <a:fillRect/>
+          </a:stretch>
+        </p:blipFill>
+        <p:spPr>
+          <a:xfrm>
+            <a:off x="2011680" y="1371600"/>
+            <a:ext cx="8229600" cy="5052889"/>
+          </a:xfrm>
+          <a:prstGeom prst="rect">
+            <a:avLst/>
+          </a:prstGeom>
+        </p:spPr>
+      </p:pic>
     </p:spTree>
   </p:cSld>
   <p:clrMapOvr>
@@ -9130,12 +9261,12 @@
       <p:grpSpPr/>
       <p:sp>
         <p:nvSpPr>
-          <p:cNvPr id="2" name="Title 1"/>
+          <p:cNvPr id="2" name="Text Placeholder 1"/>
           <p:cNvSpPr>
             <a:spLocks noGrp="1"/>
           </p:cNvSpPr>
           <p:nvPr>
-            <p:ph type="title"/>
+            <p:ph type="body" idx="13" sz="quarter"/>
           </p:nvPr>
         </p:nvSpPr>
         <p:spPr/>
@@ -9144,19 +9275,24 @@
           <a:lstStyle/>
           <a:p>
             <a:r>
-              <a:t>Real-Life Example: Phishing URL Detector</a:t>
+              <a:t>Phishing URL</a:t>
+            </a:r>
+          </a:p>
+          <a:p>
+            <a:r>
+              <a:t>Detection</a:t>
             </a:r>
           </a:p>
         </p:txBody>
       </p:sp>
       <p:sp>
         <p:nvSpPr>
-          <p:cNvPr id="3" name="Content Placeholder 2"/>
+          <p:cNvPr id="3" name="Text Placeholder 2"/>
           <p:cNvSpPr>
             <a:spLocks noGrp="1"/>
           </p:cNvSpPr>
           <p:nvPr>
-            <p:ph idx="1"/>
+            <p:ph type="body" idx="16" sz="quarter"/>
           </p:nvPr>
         </p:nvSpPr>
         <p:spPr/>
@@ -9164,51 +9300,8 @@
           <a:bodyPr/>
           <a:lstStyle/>
           <a:p>
-            <a:pPr/>
-            <a:r>
-              <a:t>A phishing URL often has telltale signs:</a:t>
-            </a:r>
-          </a:p>
-          <a:p>
-            <a:pPr lvl="1"/>
-            <a:r>
-              <a:t>Very long URL — to hide the real domain in the path</a:t>
-            </a:r>
-          </a:p>
-          <a:p>
-            <a:pPr lvl="1"/>
-            <a:r>
-              <a:t>Many dots — paypal.verify.account.evil.com</a:t>
-            </a:r>
-          </a:p>
-          <a:p>
-            <a:pPr lvl="1"/>
-            <a:r>
-              <a:t>Contains @ symbol — browser ignores everything before @</a:t>
-            </a:r>
-          </a:p>
-          <a:p>
-            <a:pPr lvl="1"/>
-            <a:r>
-              <a:t>Uses an IP address instead of a domain name</a:t>
-            </a:r>
-          </a:p>
-          <a:p>
-            <a:pPr lvl="1"/>
-            <a:r>
-              <a:t>Many hyphens in the domain</a:t>
-            </a:r>
-          </a:p>
-          <a:p>
-            <a:pPr/>
-            <a:r>
-              <a:t>We extract these as numerical features and train a classifier</a:t>
-            </a:r>
-          </a:p>
-          <a:p>
-            <a:pPr/>
-            <a:r>
-              <a:t>Label: phishing (1) or legitimate (0)</a:t>
+            <a:r>
+              <a:t>02</a:t>
             </a:r>
           </a:p>
         </p:txBody>
@@ -9247,69 +9340,35 @@
           <a:lstStyle/>
           <a:p>
             <a:r>
-              <a:t>Decision Boundary</a:t>
+              <a:t>Phishing URL Red Flags — Extractable as Features</a:t>
             </a:r>
           </a:p>
         </p:txBody>
       </p:sp>
-      <p:sp>
-        <p:nvSpPr>
-          <p:cNvPr id="3" name="Content Placeholder 2"/>
-          <p:cNvSpPr>
-            <a:spLocks noGrp="1"/>
-          </p:cNvSpPr>
-          <p:nvPr>
-            <p:ph idx="1"/>
-          </p:nvPr>
-        </p:nvSpPr>
-        <p:spPr/>
-        <p:txBody>
-          <a:bodyPr/>
-          <a:lstStyle/>
-          <a:p>
-            <a:pPr/>
-            <a:r>
-              <a:t>The model learns a boundary that separates the two classes</a:t>
-            </a:r>
-          </a:p>
-          <a:p>
-            <a:pPr/>
-            <a:r>
-              <a:t>In 2D: a line. In many dimensions: a hyperplane</a:t>
-            </a:r>
-          </a:p>
-          <a:p>
-            <a:pPr/>
-            <a:r>
-              <a:t>Everything on one side → phishing, the other → legitimate</a:t>
-            </a:r>
-          </a:p>
-          <a:p>
-            <a:pPr/>
-            <a:r>
-              <a:t>Two ways to get predictions:</a:t>
-            </a:r>
-          </a:p>
-          <a:p>
-            <a:pPr lvl="1"/>
-            <a:r>
-              <a:t>model.predict(X) — returns 0 or 1 (hard label, uses 0.5 threshold)</a:t>
-            </a:r>
-          </a:p>
-          <a:p>
-            <a:pPr lvl="1"/>
-            <a:r>
-              <a:t>model.predict_proba(X) — returns [P(legit), P(phishing)]</a:t>
-            </a:r>
-          </a:p>
-          <a:p>
-            <a:pPr/>
-            <a:r>
-              <a:t>Probabilities give you more control than hard labels</a:t>
-            </a:r>
-          </a:p>
-        </p:txBody>
-      </p:sp>
+      <p:pic>
+        <p:nvPicPr>
+          <p:cNvPr id="3" name="Picture 2" descr="log_features.png"/>
+          <p:cNvPicPr>
+            <a:picLocks noChangeAspect="1"/>
+          </p:cNvPicPr>
+          <p:nvPr/>
+        </p:nvPicPr>
+        <p:blipFill>
+          <a:blip r:embed="rId2"/>
+          <a:stretch>
+            <a:fillRect/>
+          </a:stretch>
+        </p:blipFill>
+        <p:spPr>
+          <a:xfrm>
+            <a:off x="1097280" y="1188720"/>
+            <a:ext cx="10058400" cy="5577687"/>
+          </a:xfrm>
+          <a:prstGeom prst="rect">
+            <a:avLst/>
+          </a:prstGeom>
+        </p:spPr>
+      </p:pic>
     </p:spTree>
   </p:cSld>
   <p:clrMapOvr>
@@ -9330,12 +9389,12 @@
       <p:grpSpPr/>
       <p:sp>
         <p:nvSpPr>
-          <p:cNvPr id="2" name="Text Placeholder 1"/>
+          <p:cNvPr id="2" name="Title 1"/>
           <p:cNvSpPr>
             <a:spLocks noGrp="1"/>
           </p:cNvSpPr>
           <p:nvPr>
-            <p:ph type="body" idx="13" sz="quarter"/>
+            <p:ph type="title"/>
           </p:nvPr>
         </p:nvSpPr>
         <p:spPr/>
@@ -9344,37 +9403,35 @@
           <a:lstStyle/>
           <a:p>
             <a:r>
-              <a:t>Thresholds &amp;</a:t>
-            </a:r>
-          </a:p>
-          <a:p>
-            <a:r>
-              <a:t>Coefficients</a:t>
+              <a:t>Feature Coefficients — What Drives the Prediction</a:t>
             </a:r>
           </a:p>
         </p:txBody>
       </p:sp>
-      <p:sp>
-        <p:nvSpPr>
-          <p:cNvPr id="3" name="Text Placeholder 2"/>
-          <p:cNvSpPr>
-            <a:spLocks noGrp="1"/>
-          </p:cNvSpPr>
-          <p:nvPr>
-            <p:ph type="body" idx="16" sz="quarter"/>
-          </p:nvPr>
-        </p:nvSpPr>
-        <p:spPr/>
-        <p:txBody>
-          <a:bodyPr/>
-          <a:lstStyle/>
-          <a:p>
-            <a:r>
-              <a:t>03</a:t>
-            </a:r>
-          </a:p>
-        </p:txBody>
-      </p:sp>
+      <p:pic>
+        <p:nvPicPr>
+          <p:cNvPr id="3" name="Picture 2" descr="log_coefs.png"/>
+          <p:cNvPicPr>
+            <a:picLocks noChangeAspect="1"/>
+          </p:cNvPicPr>
+          <p:nvPr/>
+        </p:nvPicPr>
+        <p:blipFill>
+          <a:blip r:embed="rId2"/>
+          <a:stretch>
+            <a:fillRect/>
+          </a:stretch>
+        </p:blipFill>
+        <p:spPr>
+          <a:xfrm>
+            <a:off x="2011680" y="1371600"/>
+            <a:ext cx="8229600" cy="7107964"/>
+          </a:xfrm>
+          <a:prstGeom prst="rect">
+            <a:avLst/>
+          </a:prstGeom>
+        </p:spPr>
+      </p:pic>
     </p:spTree>
   </p:cSld>
   <p:clrMapOvr>
@@ -9395,7 +9452,59 @@
       <p:grpSpPr/>
       <p:sp>
         <p:nvSpPr>
-          <p:cNvPr id="2" name="Title 1"/>
+          <p:cNvPr id="2" name="Text Placeholder 1"/>
+          <p:cNvSpPr>
+            <a:spLocks noGrp="1"/>
+          </p:cNvSpPr>
+          <p:nvPr>
+            <p:ph type="body" idx="14" sz="quarter"/>
+          </p:nvPr>
+        </p:nvSpPr>
+        <p:spPr/>
+        <p:txBody>
+          <a:bodyPr/>
+          <a:lstStyle/>
+          <a:p>
+            <a:r>
+              <a:t>— Interpretability matters in security</a:t>
+            </a:r>
+          </a:p>
+        </p:txBody>
+      </p:sp>
+      <p:sp>
+        <p:nvSpPr>
+          <p:cNvPr id="3" name="Text Placeholder 2"/>
+          <p:cNvSpPr>
+            <a:spLocks noGrp="1"/>
+          </p:cNvSpPr>
+          <p:nvPr>
+            <p:ph type="body" idx="15" sz="quarter"/>
+          </p:nvPr>
+        </p:nvSpPr>
+        <p:spPr/>
+        <p:txBody>
+          <a:bodyPr/>
+          <a:lstStyle/>
+          <a:p>
+            <a:r>
+              <a:t>You can explain to a</a:t>
+            </a:r>
+          </a:p>
+          <a:p>
+            <a:r>
+              <a:t>non-technical stakeholder</a:t>
+            </a:r>
+          </a:p>
+          <a:p>
+            <a:r>
+              <a:t>exactly why a URL was flagged.</a:t>
+            </a:r>
+          </a:p>
+        </p:txBody>
+      </p:sp>
+      <p:sp>
+        <p:nvSpPr>
+          <p:cNvPr id="4" name="Title 3"/>
           <p:cNvSpPr>
             <a:spLocks noGrp="1"/>
           </p:cNvSpPr>
@@ -9409,19 +9518,19 @@
           <a:lstStyle/>
           <a:p>
             <a:r>
-              <a:t>Threshold Tuning</a:t>
+              <a:t>Interpreting Coefficients</a:t>
             </a:r>
           </a:p>
         </p:txBody>
       </p:sp>
       <p:sp>
         <p:nvSpPr>
-          <p:cNvPr id="3" name="Content Placeholder 2"/>
+          <p:cNvPr id="5" name="Text Placeholder 4"/>
           <p:cNvSpPr>
             <a:spLocks noGrp="1"/>
           </p:cNvSpPr>
           <p:nvPr>
-            <p:ph idx="1"/>
+            <p:ph type="body" idx="16" sz="quarter"/>
           </p:nvPr>
         </p:nvSpPr>
         <p:spPr/>
@@ -9431,49 +9540,40 @@
           <a:p>
             <a:pPr/>
             <a:r>
-              <a:t>Default threshold: 0.5 — but this is not always optimal</a:t>
+              <a:t>model.coef_ shows feature impact:</a:t>
+            </a:r>
+          </a:p>
+          <a:p>
+            <a:pPr lvl="1"/>
+            <a:r>
+              <a:t>Positive → increases P(phishing)</a:t>
+            </a:r>
+          </a:p>
+          <a:p>
+            <a:pPr lvl="1"/>
+            <a:r>
+              <a:t>Negative → decreases P(phishing)</a:t>
             </a:r>
           </a:p>
           <a:p>
             <a:pPr/>
-            <a:r>
-              <a:t>Lower threshold (e.g. 0.3):</a:t>
+          </a:p>
+          <a:p>
+            <a:pPr/>
+            <a:r>
+              <a:t>Directly interpretable:</a:t>
             </a:r>
           </a:p>
           <a:p>
             <a:pPr lvl="1"/>
             <a:r>
-              <a:t>Catches more phishing (higher recall)</a:t>
+              <a:t>num_dots: +1.45 (highly suspicious)</a:t>
             </a:r>
           </a:p>
           <a:p>
             <a:pPr lvl="1"/>
             <a:r>
-              <a:t>Generates more false alarms (lower precision)</a:t>
-            </a:r>
-          </a:p>
-          <a:p>
-            <a:pPr/>
-            <a:r>
-              <a:t>Higher threshold (e.g. 0.7):</a:t>
-            </a:r>
-          </a:p>
-          <a:p>
-            <a:pPr lvl="1"/>
-            <a:r>
-              <a:t>Fewer false alarms (higher precision)</a:t>
-            </a:r>
-          </a:p>
-          <a:p>
-            <a:pPr lvl="1"/>
-            <a:r>
-              <a:t>Misses more subtle phishing (lower recall)</a:t>
-            </a:r>
-          </a:p>
-          <a:p>
-            <a:pPr/>
-            <a:r>
-              <a:t>The right choice depends on your operational priorities</a:t>
+              <a:t>domain_age: −0.91 (older = trustworthy)</a:t>
             </a:r>
           </a:p>
         </p:txBody>

</xml_diff>